<commit_message>
Link the live Streamlit dashboard
Add the deployed app URL to the README, app/README.md, the final
report, and the dashboard slide (clickable link + speaker note).

Co-Authored-By: Claude Opus 5.5 <noreply@anthropic.com>
Claude-Session: https://claude.ai/code/session_01LSZTQrqCkEojaZA16W6yda
</commit_message>
<xml_diff>
--- a/slides/immuno_compass.pptx
+++ b/slides/immuno_compass.pptx
@@ -124,51 +124,51 @@
   <p:extLst>
     <p:ext uri="{521415D9-36F7-43E2-AB2F-B90AF26B5E84}">
       <p14:sectionLst xmlns:p14="http://schemas.microsoft.com/office/powerpoint/2010/main">
-        <p14:section name="Introduction" id="{dd603fb9-6ebb-d7ee-ea52-1d33289abd98}">
+        <p14:section name="Introduction" id="{c38cb587-5bc6-86b3-7037-baceae44be10}">
           <p14:sldIdLst>
             <p14:sldId id="256"/>
             <p14:sldId id="257"/>
           </p14:sldIdLst>
         </p14:section>
-        <p14:section name="Data" id="{5c978291-2013-a68f-3f57-87ef72a1117f}">
+        <p14:section name="Data" id="{f7285d03-0cb1-436e-c97f-95311c163973}">
           <p14:sldIdLst>
             <p14:sldId id="258"/>
             <p14:sldId id="259"/>
           </p14:sldIdLst>
         </p14:section>
-        <p14:section name="Exploration" id="{57f1a8b1-710a-c32c-a780-5a5852916f08}">
+        <p14:section name="Exploration" id="{d4c10bc2-4bcb-f053-cc87-dba54661999c}">
           <p14:sldIdLst>
             <p14:sldId id="260"/>
             <p14:sldId id="261"/>
           </p14:sldIdLst>
         </p14:section>
-        <p14:section name="Methods" id="{73632e36-9bef-c737-a716-6d8c4728adda}">
+        <p14:section name="Methods" id="{ccc37373-f81a-f933-4264-38fbd5728339}">
           <p14:sldIdLst>
             <p14:sldId id="262"/>
             <p14:sldId id="263"/>
             <p14:sldId id="264"/>
           </p14:sldIdLst>
         </p14:section>
-        <p14:section name="Results" id="{6dc60cb4-f73a-ab8b-56a3-c8d313ed48b7}">
+        <p14:section name="Results" id="{2553ace1-bb12-edc7-48ef-1c46bcf83858}">
           <p14:sldIdLst>
             <p14:sldId id="265"/>
             <p14:sldId id="266"/>
             <p14:sldId id="267"/>
           </p14:sldIdLst>
         </p14:section>
-        <p14:section name="What drives ADA" id="{ea7363cf-80ce-f6bf-9613-07da8007e552}">
+        <p14:section name="What drives ADA" id="{0e7d6eaa-ecca-2c5e-2c55-0cb6191898e2}">
           <p14:sldIdLst>
             <p14:sldId id="268"/>
             <p14:sldId id="269"/>
           </p14:sldIdLst>
         </p14:section>
-        <p14:section name="Extensions" id="{c215ddf5-b5fb-6910-0c73-85d21e28e624}">
+        <p14:section name="Extensions" id="{508a9d63-df3c-4118-a822-3782ab5924f7}">
           <p14:sldIdLst>
             <p14:sldId id="270"/>
             <p14:sldId id="271"/>
           </p14:sldIdLst>
         </p14:section>
-        <p14:section name="Conclusion" id="{8057d5a1-a185-305c-64f4-ac92c8c1041a}">
+        <p14:section name="Conclusion" id="{1886212e-a7a8-802f-1e0c-7f408162db38}">
           <p14:sldIdLst>
             <p14:sldId id="272"/>
             <p14:sldId id="273"/>
@@ -1194,7 +1194,7 @@
           <a:p>
             <a:r>
               <a:rPr lang="en-US" dirty="0"/>
-              <a:t>The fourth deliverable is an interactive Streamlit dashboard. In the Explore tab you can group ADA frequency by origin, route, disease area or dose and filter the data. In the Predict tab you describe a drug and a trial and get the XGBoost estimate and the Bayesian Beta-Binomial range, including how many patients out of a group of your chosen size might be ADA-positive. The app never retrains; it loads the saved models together with their preprocessing, which avoids the classic mismatch between training and the app. If time allows, I can show it live.</a:t>
+              <a:t>The fourth deliverable is an interactive Streamlit dashboard. In the Explore tab you can group ADA frequency by origin, route, disease area or dose and filter the data. In the Predict tab you describe a drug and a trial and get the XGBoost estimate and the Bayesian Beta-Binomial range, including how many patients out of a group of your chosen size might be ADA-positive. The app never retrains; it loads the saved models together with their preprocessing, which avoids the classic mismatch between training and the app. It is online at https://immuno-compass-6vv9xjcxqs9rzp6dztbn2x.streamlit.app, and if time allows I can show it live.</a:t>
             </a:r>
             <a:endParaRPr lang="en-US" dirty="0"/>
           </a:p>
@@ -4743,7 +4743,7 @@
         <p:spPr>
           <a:xfrm>
             <a:off x="7726680" y="1600200"/>
-            <a:ext cx="3703320" cy="4480560"/>
+            <a:ext cx="3703320" cy="3566160"/>
           </a:xfrm>
           <a:prstGeom prst="rect">
             <a:avLst/>
@@ -4823,6 +4823,63 @@
                 </a:solidFill>
               </a:rPr>
               <a:t>Loads the saved models, so it uses exactly the training preprocessing</a:t>
+            </a:r>
+            <a:endParaRPr lang="en-US" sz="1600" dirty="0"/>
+          </a:p>
+        </p:txBody>
+      </p:sp>
+      <p:sp>
+        <p:nvSpPr>
+          <p:cNvPr id="6" name="dashboard link"/>
+          <p:cNvSpPr txBox="1"/>
+          <p:nvPr/>
+        </p:nvSpPr>
+        <p:spPr>
+          <a:xfrm>
+            <a:off x="7726680" y="5257800"/>
+            <a:ext cx="3703320" cy="777240"/>
+          </a:xfrm>
+          <a:prstGeom prst="rect">
+            <a:avLst/>
+          </a:prstGeom>
+          <a:noFill/>
+          <a:ln/>
+        </p:spPr>
+        <p:txBody>
+          <a:bodyPr wrap="square" lIns="0" tIns="0" rIns="0" bIns="0" rtlCol="0" anchor="t"/>
+          <a:lstStyle/>
+          <a:p>
+            <a:pPr indent="0" marL="0">
+              <a:buNone/>
+            </a:pPr>
+            <a:r>
+              <a:rPr lang="en-US" sz="1600" b="1" dirty="0">
+                <a:solidFill>
+                  <a:schemeClr val="tx2"/>
+                </a:solidFill>
+              </a:rPr>
+              <a:t>Try it live</a:t>
+            </a:r>
+            <a:endParaRPr lang="en-US" sz="1600" dirty="0"/>
+          </a:p>
+          <a:p>
+            <a:pPr indent="0" marL="0">
+              <a:buNone/>
+            </a:pPr>
+            <a:r>
+              <a:rPr lang="en-US" sz="1600" u="sng" dirty="0">
+                <a:solidFill>
+                  <a:schemeClr val="accent2"/>
+                </a:solidFill>
+                <a:hlinkClick r:id="rId2" invalidUrl="" action="" tgtFrame="" tooltip="" history="1" highlightClick="0" endSnd="0">
+                  <a:extLst>
+                    <a:ext uri="{A12FA001-AC4F-418D-AE19-62706E023703}">
+                      <ahyp:hlinkClr xmlns:ahyp="http://schemas.microsoft.com/office/drawing/2018/hyperlinkcolor" val="tx"/>
+                    </a:ext>
+                  </a:extLst>
+                </a:hlinkClick>
+              </a:rPr>
+              <a:t>immuno-compass…streamlit.app</a:t>
             </a:r>
             <a:endParaRPr lang="en-US" sz="1600" dirty="0"/>
           </a:p>

</xml_diff>

<commit_message>
Add presenter name to the title slide
Title slide now shows "Siya Salim" under the subtitle; the opening
speaker note introduces her by name (speaker script regenerated).

Co-Authored-By: Claude Opus 5.5 <noreply@anthropic.com>
Claude-Session: https://claude.ai/code/session_01LSZTQrqCkEojaZA16W6yda
</commit_message>
<xml_diff>
--- a/slides/immuno_compass.pptx
+++ b/slides/immuno_compass.pptx
@@ -124,51 +124,51 @@
   <p:extLst>
     <p:ext uri="{521415D9-36F7-43E2-AB2F-B90AF26B5E84}">
       <p14:sectionLst xmlns:p14="http://schemas.microsoft.com/office/powerpoint/2010/main">
-        <p14:section name="Introduction" id="{c38cb587-5bc6-86b3-7037-baceae44be10}">
+        <p14:section name="Introduction" id="{9d6fe054-ff23-274e-bca0-3900235d86fb}">
           <p14:sldIdLst>
             <p14:sldId id="256"/>
             <p14:sldId id="257"/>
           </p14:sldIdLst>
         </p14:section>
-        <p14:section name="Data" id="{f7285d03-0cb1-436e-c97f-95311c163973}">
+        <p14:section name="Data" id="{af24171e-7c97-c956-dbda-dc5605577e2f}">
           <p14:sldIdLst>
             <p14:sldId id="258"/>
             <p14:sldId id="259"/>
           </p14:sldIdLst>
         </p14:section>
-        <p14:section name="Exploration" id="{d4c10bc2-4bcb-f053-cc87-dba54661999c}">
+        <p14:section name="Exploration" id="{01f4df0c-fbe6-03e5-6172-db7b87dc783e}">
           <p14:sldIdLst>
             <p14:sldId id="260"/>
             <p14:sldId id="261"/>
           </p14:sldIdLst>
         </p14:section>
-        <p14:section name="Methods" id="{ccc37373-f81a-f933-4264-38fbd5728339}">
+        <p14:section name="Methods" id="{26101e5a-0a4f-3796-26d5-efd671053dc8}">
           <p14:sldIdLst>
             <p14:sldId id="262"/>
             <p14:sldId id="263"/>
             <p14:sldId id="264"/>
           </p14:sldIdLst>
         </p14:section>
-        <p14:section name="Results" id="{2553ace1-bb12-edc7-48ef-1c46bcf83858}">
+        <p14:section name="Results" id="{5a59e3d0-88c5-c8e5-92a8-467e89dcbf7f}">
           <p14:sldIdLst>
             <p14:sldId id="265"/>
             <p14:sldId id="266"/>
             <p14:sldId id="267"/>
           </p14:sldIdLst>
         </p14:section>
-        <p14:section name="What drives ADA" id="{0e7d6eaa-ecca-2c5e-2c55-0cb6191898e2}">
+        <p14:section name="What drives ADA" id="{97a315d4-4100-5500-e3d5-483d5aa4978f}">
           <p14:sldIdLst>
             <p14:sldId id="268"/>
             <p14:sldId id="269"/>
           </p14:sldIdLst>
         </p14:section>
-        <p14:section name="Extensions" id="{508a9d63-df3c-4118-a822-3782ab5924f7}">
+        <p14:section name="Extensions" id="{ec031354-3a6b-c3dc-fc80-2b9f6a48bd34}">
           <p14:sldIdLst>
             <p14:sldId id="270"/>
             <p14:sldId id="271"/>
           </p14:sldIdLst>
         </p14:section>
-        <p14:section name="Conclusion" id="{1886212e-a7a8-802f-1e0c-7f408162db38}">
+        <p14:section name="Conclusion" id="{7e0e0f06-e45e-5888-c06f-7685ac85bfae}">
           <p14:sldIdLst>
             <p14:sldId id="272"/>
             <p14:sldId id="273"/>
@@ -578,7 +578,7 @@
           <a:p>
             <a:r>
               <a:rPr lang="en-US" dirty="0"/>
-              <a:t>Hello everyone. My project is called Immuno Compass. It is about a safety and effectiveness problem with modern biologic medicines: sometimes the patient's immune system attacks the drug. I used a newly consolidated public database of clinical trials to ask two questions: can we predict how often this happens for a drug, and which factors are linked to it? I will walk you through the data, the three modelling approaches, an honest comparison, and what the models agree on.</a:t>
+              <a:t>Hello everyone, I am Siya Salim. My project is called Immuno Compass. It is about a safety and effectiveness problem with modern biologic medicines: sometimes the patient's immune system attacks the drug. I used a newly consolidated public database of clinical trials to ask two questions: can we predict how often this happens for a drug, and which factors are linked to it? I will walk you through the data, the three modelling approaches, an honest comparison, and what the models agree on.</a:t>
             </a:r>
             <a:endParaRPr lang="en-US" dirty="0"/>
           </a:p>
@@ -2965,6 +2965,42 @@
               <a:t>Foundations of Data Science · course project</a:t>
             </a:r>
             <a:endParaRPr lang="en-US" sz="2200" dirty="0"/>
+          </a:p>
+        </p:txBody>
+      </p:sp>
+      <p:sp>
+        <p:nvSpPr>
+          <p:cNvPr id="4" name="presenter name"/>
+          <p:cNvSpPr txBox="1"/>
+          <p:nvPr/>
+        </p:nvSpPr>
+        <p:spPr>
+          <a:xfrm>
+            <a:off x="822960" y="5257800"/>
+            <a:ext cx="10058400" cy="548640"/>
+          </a:xfrm>
+          <a:prstGeom prst="rect">
+            <a:avLst/>
+          </a:prstGeom>
+          <a:noFill/>
+          <a:ln/>
+        </p:spPr>
+        <p:txBody>
+          <a:bodyPr wrap="square" lIns="0" tIns="0" rIns="0" bIns="0" rtlCol="0" anchor="ctr"/>
+          <a:lstStyle/>
+          <a:p>
+            <a:pPr indent="0" marL="0">
+              <a:buNone/>
+            </a:pPr>
+            <a:r>
+              <a:rPr lang="en-US" sz="2400" b="1" dirty="0">
+                <a:solidFill>
+                  <a:schemeClr val="bg1"/>
+                </a:solidFill>
+              </a:rPr>
+              <a:t>Siya Salim</a:t>
+            </a:r>
+            <a:endParaRPr lang="en-US" sz="2400" dirty="0"/>
           </a:p>
         </p:txBody>
       </p:sp>

</xml_diff>